<commit_message>
feat: Phase 13.5 — first-minute wow + update README/PPT/PDF for Phase 13
Ties the front door into a seamless first run: a fresh account can reach a
working project in under a minute, fully offline.

- web TaskInput: suggested one-click first tasks so a freshly-opened project
  isn't a blank box.
- tests/test_first_run_e2e: end-to-end offline proof — register → bootstrap a
  fastapi-saas project → run the team → files on disk → scored in analytics.
  Suite 329 -> 330.
- README: new 'Projects & first-run (Phase 13)' section, updated UI flow
  (project chooser), status table (13 phases), counts (330 tests / 26 ADRs),
  project layout (+starters).
- ForgeAI-UseCases.pdf: added Example 5 (first run from nothing) — now 7 pages;
  cover + footer updated.
- ForgeAI-Presentation.pptx: added a Phase 13 slide — now 10 slides; counts
  updated.
- spec acceptance box ticked.

13.5 verified offline (live click-through pending Docker restart).
</commit_message>
<xml_diff>
--- a/ForgeAI-Presentation.pptx
+++ b/ForgeAI-Presentation.pptx
@@ -14,6 +14,7 @@
     <p:sldId id="262" r:id="rId13"/>
     <p:sldId id="263" r:id="rId14"/>
     <p:sldId id="264" r:id="rId15"/>
+    <p:sldId id="265" r:id="rId16"/>
   </p:sldIdLst>
   <p:sldSz cx="12192000" cy="6858000" type="screen4x3"/>
   <p:notesSz cx="6858000" cy="9144000"/>
@@ -3351,7 +3352,436 @@
                 </a:solidFill>
                 <a:latin typeface="Calibri"/>
               </a:rPr>
-              <a:t>12 phases · 310 tests · fully offline-testable · runs on local models</a:t>
+              <a:t>13 phases · 330 tests · fully offline-testable · runs on local models</a:t>
+            </a:r>
+          </a:p>
+        </p:txBody>
+      </p:sp>
+    </p:spTree>
+  </p:cSld>
+  <p:clrMapOvr>
+    <a:masterClrMapping/>
+  </p:clrMapOvr>
+</p:sld>
+</file>
+
+<file path=ppt/slides/slide10.xml><?xml version="1.0" encoding="utf-8"?>
+<p:sld xmlns:a="http://schemas.openxmlformats.org/drawingml/2006/main" xmlns:p="http://schemas.openxmlformats.org/presentationml/2006/main" xmlns:r="http://schemas.openxmlformats.org/officeDocument/2006/relationships">
+  <p:cSld>
+    <p:spTree>
+      <p:nvGrpSpPr>
+        <p:cNvPr id="1" name=""/>
+        <p:cNvGrpSpPr/>
+        <p:nvPr/>
+      </p:nvGrpSpPr>
+      <p:grpSpPr/>
+      <p:sp>
+        <p:nvSpPr>
+          <p:cNvPr id="2" name="Rectangle 1"/>
+          <p:cNvSpPr/>
+          <p:nvPr/>
+        </p:nvSpPr>
+        <p:spPr>
+          <a:xfrm>
+            <a:off x="0" y="0"/>
+            <a:ext cx="12192000" cy="6858000"/>
+          </a:xfrm>
+          <a:prstGeom prst="rect">
+            <a:avLst/>
+          </a:prstGeom>
+          <a:solidFill>
+            <a:srgbClr val="0B0E14"/>
+          </a:solidFill>
+          <a:ln>
+            <a:noFill/>
+          </a:ln>
+          <a:effectLst/>
+        </p:spPr>
+        <p:style>
+          <a:lnRef idx="1">
+            <a:schemeClr val="accent1"/>
+          </a:lnRef>
+          <a:fillRef idx="3">
+            <a:schemeClr val="accent1"/>
+          </a:fillRef>
+          <a:effectRef idx="2">
+            <a:schemeClr val="accent1"/>
+          </a:effectRef>
+          <a:fontRef idx="minor">
+            <a:schemeClr val="lt1"/>
+          </a:fontRef>
+        </p:style>
+        <p:txBody>
+          <a:bodyPr rtlCol="0" anchor="ctr"/>
+          <a:lstStyle/>
+          <a:p>
+            <a:pPr algn="ctr"/>
+          </a:p>
+        </p:txBody>
+      </p:sp>
+      <p:sp>
+        <p:nvSpPr>
+          <p:cNvPr id="3" name="TextBox 2"/>
+          <p:cNvSpPr txBox="1"/>
+          <p:nvPr/>
+        </p:nvSpPr>
+        <p:spPr>
+          <a:xfrm>
+            <a:off x="700000" y="520000"/>
+            <a:ext cx="8000000" cy="400000"/>
+          </a:xfrm>
+          <a:prstGeom prst="rect">
+            <a:avLst/>
+          </a:prstGeom>
+          <a:noFill/>
+        </p:spPr>
+        <p:txBody>
+          <a:bodyPr wrap="square" anchor="t">
+            <a:spAutoFit/>
+          </a:bodyPr>
+          <a:lstStyle/>
+          <a:p>
+            <a:pPr algn="l">
+              <a:spcAft>
+                <a:spcPts val="600"/>
+              </a:spcAft>
+            </a:pPr>
+            <a:r>
+              <a:rPr sz="1300" b="1">
+                <a:solidFill>
+                  <a:srgbClr val="4F9CF5"/>
+                </a:solidFill>
+                <a:latin typeface="Calibri"/>
+              </a:rPr>
+              <a:t>STACK &amp; STATUS</a:t>
+            </a:r>
+          </a:p>
+        </p:txBody>
+      </p:sp>
+      <p:sp>
+        <p:nvSpPr>
+          <p:cNvPr id="4" name="TextBox 3"/>
+          <p:cNvSpPr txBox="1"/>
+          <p:nvPr/>
+        </p:nvSpPr>
+        <p:spPr>
+          <a:xfrm>
+            <a:off x="700000" y="820000"/>
+            <a:ext cx="10800000" cy="900000"/>
+          </a:xfrm>
+          <a:prstGeom prst="rect">
+            <a:avLst/>
+          </a:prstGeom>
+          <a:noFill/>
+        </p:spPr>
+        <p:txBody>
+          <a:bodyPr wrap="square" anchor="t">
+            <a:spAutoFit/>
+          </a:bodyPr>
+          <a:lstStyle/>
+          <a:p>
+            <a:pPr algn="l">
+              <a:spcAft>
+                <a:spcPts val="600"/>
+              </a:spcAft>
+            </a:pPr>
+            <a:r>
+              <a:rPr sz="3400" b="1">
+                <a:solidFill>
+                  <a:srgbClr val="F2F4F8"/>
+                </a:solidFill>
+                <a:latin typeface="Calibri"/>
+              </a:rPr>
+              <a:t>Built, tested, and running</a:t>
+            </a:r>
+          </a:p>
+        </p:txBody>
+      </p:sp>
+      <p:sp>
+        <p:nvSpPr>
+          <p:cNvPr id="5" name="TextBox 4"/>
+          <p:cNvSpPr txBox="1"/>
+          <p:nvPr/>
+        </p:nvSpPr>
+        <p:spPr>
+          <a:xfrm>
+            <a:off x="700000" y="1950000"/>
+            <a:ext cx="11000000" cy="2600000"/>
+          </a:xfrm>
+          <a:prstGeom prst="rect">
+            <a:avLst/>
+          </a:prstGeom>
+          <a:noFill/>
+        </p:spPr>
+        <p:txBody>
+          <a:bodyPr wrap="square">
+            <a:spAutoFit/>
+          </a:bodyPr>
+          <a:lstStyle/>
+          <a:p>
+            <a:pPr>
+              <a:spcAft>
+                <a:spcPts val="1100"/>
+              </a:spcAft>
+            </a:pPr>
+            <a:r>
+              <a:rPr sz="1600" b="1">
+                <a:solidFill>
+                  <a:srgbClr val="4F9CF5"/>
+                </a:solidFill>
+              </a:rPr>
+              <a:t>▸ </a:t>
+            </a:r>
+            <a:r>
+              <a:rPr sz="1600" b="1">
+                <a:solidFill>
+                  <a:srgbClr val="F2F4F8"/>
+                </a:solidFill>
+                <a:latin typeface="Calibri"/>
+              </a:rPr>
+              <a:t>Frontend</a:t>
+            </a:r>
+            <a:r>
+              <a:rPr sz="1600">
+                <a:solidFill>
+                  <a:srgbClr val="9AA4B2"/>
+                </a:solidFill>
+                <a:latin typeface="Calibri"/>
+              </a:rPr>
+              <a:t> — Next.js · React · TypeScript · Tailwind</a:t>
+            </a:r>
+          </a:p>
+          <a:p>
+            <a:pPr>
+              <a:spcAft>
+                <a:spcPts val="1100"/>
+              </a:spcAft>
+            </a:pPr>
+            <a:r>
+              <a:rPr sz="1600" b="1">
+                <a:solidFill>
+                  <a:srgbClr val="4F9CF5"/>
+                </a:solidFill>
+              </a:rPr>
+              <a:t>▸ </a:t>
+            </a:r>
+            <a:r>
+              <a:rPr sz="1600" b="1">
+                <a:solidFill>
+                  <a:srgbClr val="F2F4F8"/>
+                </a:solidFill>
+                <a:latin typeface="Calibri"/>
+              </a:rPr>
+              <a:t>Backend</a:t>
+            </a:r>
+            <a:r>
+              <a:rPr sz="1600">
+                <a:solidFill>
+                  <a:srgbClr val="9AA4B2"/>
+                </a:solidFill>
+                <a:latin typeface="Calibri"/>
+              </a:rPr>
+              <a:t> — FastAPI · LangGraph · SQLAlchemy (async) · WebSockets</a:t>
+            </a:r>
+          </a:p>
+          <a:p>
+            <a:pPr>
+              <a:spcAft>
+                <a:spcPts val="1100"/>
+              </a:spcAft>
+            </a:pPr>
+            <a:r>
+              <a:rPr sz="1600" b="1">
+                <a:solidFill>
+                  <a:srgbClr val="4F9CF5"/>
+                </a:solidFill>
+              </a:rPr>
+              <a:t>▸ </a:t>
+            </a:r>
+            <a:r>
+              <a:rPr sz="1600" b="1">
+                <a:solidFill>
+                  <a:srgbClr val="F2F4F8"/>
+                </a:solidFill>
+                <a:latin typeface="Calibri"/>
+              </a:rPr>
+              <a:t>Data</a:t>
+            </a:r>
+            <a:r>
+              <a:rPr sz="1600">
+                <a:solidFill>
+                  <a:srgbClr val="9AA4B2"/>
+                </a:solidFill>
+                <a:latin typeface="Calibri"/>
+              </a:rPr>
+              <a:t> — PostgreSQL · Redis · Qdrant</a:t>
+            </a:r>
+          </a:p>
+          <a:p>
+            <a:pPr>
+              <a:spcAft>
+                <a:spcPts val="1100"/>
+              </a:spcAft>
+            </a:pPr>
+            <a:r>
+              <a:rPr sz="1600" b="1">
+                <a:solidFill>
+                  <a:srgbClr val="4F9CF5"/>
+                </a:solidFill>
+              </a:rPr>
+              <a:t>▸ </a:t>
+            </a:r>
+            <a:r>
+              <a:rPr sz="1600" b="1">
+                <a:solidFill>
+                  <a:srgbClr val="F2F4F8"/>
+                </a:solidFill>
+                <a:latin typeface="Calibri"/>
+              </a:rPr>
+              <a:t>AI</a:t>
+            </a:r>
+            <a:r>
+              <a:rPr sz="1600">
+                <a:solidFill>
+                  <a:srgbClr val="9AA4B2"/>
+                </a:solidFill>
+                <a:latin typeface="Calibri"/>
+              </a:rPr>
+              <a:t> — Ollama (local) · model-router abstraction · LangGraph</a:t>
+            </a:r>
+          </a:p>
+          <a:p>
+            <a:pPr>
+              <a:spcAft>
+                <a:spcPts val="1100"/>
+              </a:spcAft>
+            </a:pPr>
+            <a:r>
+              <a:rPr sz="1600" b="1">
+                <a:solidFill>
+                  <a:srgbClr val="4F9CF5"/>
+                </a:solidFill>
+              </a:rPr>
+              <a:t>▸ </a:t>
+            </a:r>
+            <a:r>
+              <a:rPr sz="1600" b="1">
+                <a:solidFill>
+                  <a:srgbClr val="F2F4F8"/>
+                </a:solidFill>
+                <a:latin typeface="Calibri"/>
+              </a:rPr>
+              <a:t>Infra</a:t>
+            </a:r>
+            <a:r>
+              <a:rPr sz="1600">
+                <a:solidFill>
+                  <a:srgbClr val="9AA4B2"/>
+                </a:solidFill>
+                <a:latin typeface="Calibri"/>
+              </a:rPr>
+              <a:t> — Docker · Docker Compose</a:t>
+            </a:r>
+          </a:p>
+        </p:txBody>
+      </p:sp>
+      <p:sp>
+        <p:nvSpPr>
+          <p:cNvPr id="6" name="Rectangle 5"/>
+          <p:cNvSpPr/>
+          <p:nvPr/>
+        </p:nvSpPr>
+        <p:spPr>
+          <a:xfrm>
+            <a:off x="700000" y="4750000"/>
+            <a:ext cx="10900000" cy="1150000"/>
+          </a:xfrm>
+          <a:prstGeom prst="rect">
+            <a:avLst/>
+          </a:prstGeom>
+          <a:solidFill>
+            <a:srgbClr val="151A24"/>
+          </a:solidFill>
+          <a:ln w="12700">
+            <a:solidFill>
+              <a:srgbClr val="3FC97A"/>
+            </a:solidFill>
+          </a:ln>
+          <a:effectLst/>
+        </p:spPr>
+        <p:style>
+          <a:lnRef idx="1">
+            <a:schemeClr val="accent1"/>
+          </a:lnRef>
+          <a:fillRef idx="3">
+            <a:schemeClr val="accent1"/>
+          </a:fillRef>
+          <a:effectRef idx="2">
+            <a:schemeClr val="accent1"/>
+          </a:effectRef>
+          <a:fontRef idx="minor">
+            <a:schemeClr val="lt1"/>
+          </a:fontRef>
+        </p:style>
+        <p:txBody>
+          <a:bodyPr rtlCol="0" anchor="ctr"/>
+          <a:lstStyle/>
+          <a:p>
+            <a:pPr algn="ctr"/>
+          </a:p>
+        </p:txBody>
+      </p:sp>
+      <p:sp>
+        <p:nvSpPr>
+          <p:cNvPr id="7" name="TextBox 6"/>
+          <p:cNvSpPr txBox="1"/>
+          <p:nvPr/>
+        </p:nvSpPr>
+        <p:spPr>
+          <a:xfrm>
+            <a:off x="700000" y="4850000"/>
+            <a:ext cx="10900000" cy="1000000"/>
+          </a:xfrm>
+          <a:prstGeom prst="rect">
+            <a:avLst/>
+          </a:prstGeom>
+          <a:noFill/>
+        </p:spPr>
+        <p:txBody>
+          <a:bodyPr wrap="square" anchor="ctr">
+            <a:spAutoFit/>
+          </a:bodyPr>
+          <a:lstStyle/>
+          <a:p>
+            <a:pPr algn="ctr">
+              <a:spcAft>
+                <a:spcPts val="600"/>
+              </a:spcAft>
+            </a:pPr>
+            <a:r>
+              <a:rPr sz="1600" b="1">
+                <a:solidFill>
+                  <a:srgbClr val="3FC97A"/>
+                </a:solidFill>
+                <a:latin typeface="Calibri"/>
+              </a:rPr>
+              <a:t>All 13 phases complete  ·  330 tests passing  ·  26 ADRs  ·  fully documented</a:t>
+            </a:r>
+          </a:p>
+          <a:p>
+            <a:pPr algn="ctr">
+              <a:spcAft>
+                <a:spcPts val="600"/>
+              </a:spcAft>
+            </a:pPr>
+            <a:r>
+              <a:rPr sz="1400" b="0">
+                <a:solidFill>
+                  <a:srgbClr val="9AA4B2"/>
+                </a:solidFill>
+                <a:latin typeface="Calibri"/>
+              </a:rPr>
+              <a:t>From a static pipeline to a self-improving, approval-gated engineering team.</a:t>
             </a:r>
           </a:p>
         </p:txBody>
@@ -4217,7 +4647,7 @@
                 </a:solidFill>
                 <a:latin typeface="Calibri"/>
               </a:rPr>
-              <a:t> — every external dependency (LLM, GitHub, datastores) has a deterministic fake. 310 tests pass in seconds.</a:t>
+              <a:t> — every external dependency (LLM, GitHub, datastores) has a deterministic fake. 330 tests pass in seconds.</a:t>
             </a:r>
           </a:p>
         </p:txBody>
@@ -6574,7 +7004,7 @@
                 </a:solidFill>
                 <a:latin typeface="Calibri"/>
               </a:rPr>
-              <a:t>BENEFITS</a:t>
+              <a:t>FROM ENGINE TO PRODUCT — PHASE 13</a:t>
             </a:r>
           </a:p>
         </p:txBody>
@@ -6613,21 +7043,209 @@
                 </a:solidFill>
                 <a:latin typeface="Calibri"/>
               </a:rPr>
-              <a:t>Why this approach pays off</a:t>
-            </a:r>
-          </a:p>
-        </p:txBody>
-      </p:sp>
-      <p:sp>
-        <p:nvSpPr>
-          <p:cNvPr id="5" name="Rectangle 4"/>
+              <a:t>A front door: projects, bootstrap, first-minute wow</a:t>
+            </a:r>
+          </a:p>
+        </p:txBody>
+      </p:sp>
+      <p:sp>
+        <p:nvSpPr>
+          <p:cNvPr id="5" name="TextBox 4"/>
+          <p:cNvSpPr txBox="1"/>
+          <p:nvPr/>
+        </p:nvSpPr>
+        <p:spPr>
+          <a:xfrm>
+            <a:off x="700000" y="1950000"/>
+            <a:ext cx="10900000" cy="3600000"/>
+          </a:xfrm>
+          <a:prstGeom prst="rect">
+            <a:avLst/>
+          </a:prstGeom>
+          <a:noFill/>
+        </p:spPr>
+        <p:txBody>
+          <a:bodyPr wrap="square">
+            <a:spAutoFit/>
+          </a:bodyPr>
+          <a:lstStyle/>
+          <a:p>
+            <a:pPr>
+              <a:spcAft>
+                <a:spcPts val="1300"/>
+              </a:spcAft>
+            </a:pPr>
+            <a:r>
+              <a:rPr sz="1550" b="1">
+                <a:solidFill>
+                  <a:srgbClr val="4F9CF5"/>
+                </a:solidFill>
+              </a:rPr>
+              <a:t>▸ </a:t>
+            </a:r>
+            <a:r>
+              <a:rPr sz="1550" b="1">
+                <a:solidFill>
+                  <a:srgbClr val="F2F4F8"/>
+                </a:solidFill>
+                <a:latin typeface="Calibri"/>
+              </a:rPr>
+              <a:t>First-class Projects</a:t>
+            </a:r>
+            <a:r>
+              <a:rPr sz="1550">
+                <a:solidFill>
+                  <a:srgbClr val="9AA4B2"/>
+                </a:solidFill>
+                <a:latin typeface="Calibri"/>
+              </a:rPr>
+              <a:t> — each owns a real workspace directory; CRUD within the existing tenancy + RBAC</a:t>
+            </a:r>
+          </a:p>
+          <a:p>
+            <a:pPr>
+              <a:spcAft>
+                <a:spcPts val="1300"/>
+              </a:spcAft>
+            </a:pPr>
+            <a:r>
+              <a:rPr sz="1550" b="1">
+                <a:solidFill>
+                  <a:srgbClr val="4F9CF5"/>
+                </a:solidFill>
+              </a:rPr>
+              <a:t>▸ </a:t>
+            </a:r>
+            <a:r>
+              <a:rPr sz="1550" b="1">
+                <a:solidFill>
+                  <a:srgbClr val="F2F4F8"/>
+                </a:solidFill>
+                <a:latin typeface="Calibri"/>
+              </a:rPr>
+              <a:t>Runs bind to a project</a:t>
+            </a:r>
+            <a:r>
+              <a:rPr sz="1550">
+                <a:solidFill>
+                  <a:srgbClr val="9AA4B2"/>
+                </a:solidFill>
+                <a:latin typeface="Calibri"/>
+              </a:rPr>
+              <a:t> — /agents/run targets its path and writes generated files there — a real project on disk</a:t>
+            </a:r>
+          </a:p>
+          <a:p>
+            <a:pPr>
+              <a:spcAft>
+                <a:spcPts val="1300"/>
+              </a:spcAft>
+            </a:pPr>
+            <a:r>
+              <a:rPr sz="1550" b="1">
+                <a:solidFill>
+                  <a:srgbClr val="4F9CF5"/>
+                </a:solidFill>
+              </a:rPr>
+              <a:t>▸ </a:t>
+            </a:r>
+            <a:r>
+              <a:rPr sz="1550" b="1">
+                <a:solidFill>
+                  <a:srgbClr val="F2F4F8"/>
+                </a:solidFill>
+                <a:latin typeface="Calibri"/>
+              </a:rPr>
+              <a:t>Bootstrap from nothing</a:t>
+            </a:r>
+            <a:r>
+              <a:rPr sz="1550">
+                <a:solidFill>
+                  <a:srgbClr val="9AA4B2"/>
+                </a:solidFill>
+                <a:latin typeface="Calibri"/>
+              </a:rPr>
+              <a:t> — versioned starters (empty, or FastAPI + JWT + Postgres + Docker + tests) scaffold instantly, offline</a:t>
+            </a:r>
+          </a:p>
+          <a:p>
+            <a:pPr>
+              <a:spcAft>
+                <a:spcPts val="1300"/>
+              </a:spcAft>
+            </a:pPr>
+            <a:r>
+              <a:rPr sz="1550" b="1">
+                <a:solidFill>
+                  <a:srgbClr val="4F9CF5"/>
+                </a:solidFill>
+              </a:rPr>
+              <a:t>▸ </a:t>
+            </a:r>
+            <a:r>
+              <a:rPr sz="1550" b="1">
+                <a:solidFill>
+                  <a:srgbClr val="F2F4F8"/>
+                </a:solidFill>
+                <a:latin typeface="Calibri"/>
+              </a:rPr>
+              <a:t>Onboarding flow</a:t>
+            </a:r>
+            <a:r>
+              <a:rPr sz="1550">
+                <a:solidFill>
+                  <a:srgbClr val="9AA4B2"/>
+                </a:solidFill>
+                <a:latin typeface="Calibri"/>
+              </a:rPr>
+              <a:t> — sign in → project chooser (Create New / Open Existing) → workspace bound to the project</a:t>
+            </a:r>
+          </a:p>
+          <a:p>
+            <a:pPr>
+              <a:spcAft>
+                <a:spcPts val="1300"/>
+              </a:spcAft>
+            </a:pPr>
+            <a:r>
+              <a:rPr sz="1550" b="1">
+                <a:solidFill>
+                  <a:srgbClr val="4F9CF5"/>
+                </a:solidFill>
+              </a:rPr>
+              <a:t>▸ </a:t>
+            </a:r>
+            <a:r>
+              <a:rPr sz="1550" b="1">
+                <a:solidFill>
+                  <a:srgbClr val="F2F4F8"/>
+                </a:solidFill>
+                <a:latin typeface="Calibri"/>
+              </a:rPr>
+              <a:t>The first-minute wow</a:t>
+            </a:r>
+            <a:r>
+              <a:rPr sz="1550">
+                <a:solidFill>
+                  <a:srgbClr val="9AA4B2"/>
+                </a:solidFill>
+                <a:latin typeface="Calibri"/>
+              </a:rPr>
+              <a:t> — fresh account → pick a starter → watch the team build it live; works offline (MODEL_PROVIDER=echo)</a:t>
+            </a:r>
+          </a:p>
+        </p:txBody>
+      </p:sp>
+      <p:sp>
+        <p:nvSpPr>
+          <p:cNvPr id="6" name="Rectangle 5"/>
           <p:cNvSpPr/>
           <p:nvPr/>
         </p:nvSpPr>
         <p:spPr>
           <a:xfrm>
-            <a:off x="700000" y="1950000"/>
-            <a:ext cx="3450000" cy="1700000"/>
+            <a:off x="700000" y="5650000"/>
+            <a:ext cx="10900000" cy="700000"/>
           </a:xfrm>
           <a:prstGeom prst="rect">
             <a:avLst/>
@@ -6637,7 +7255,7 @@
           </a:solidFill>
           <a:ln w="12700">
             <a:solidFill>
-              <a:srgbClr val="2A3140"/>
+              <a:srgbClr val="4F9CF5"/>
             </a:solidFill>
           </a:ln>
           <a:effectLst/>
@@ -6666,14 +7284,14 @@
       </p:sp>
       <p:sp>
         <p:nvSpPr>
-          <p:cNvPr id="6" name="TextBox 5"/>
+          <p:cNvPr id="7" name="TextBox 6"/>
           <p:cNvSpPr txBox="1"/>
           <p:nvPr/>
         </p:nvSpPr>
         <p:spPr>
           <a:xfrm>
-            <a:off x="900000" y="2150000"/>
-            <a:ext cx="3050000" cy="1350000"/>
+            <a:off x="700000" y="5650000"/>
+            <a:ext cx="10900000" cy="700000"/>
           </a:xfrm>
           <a:prstGeom prst="rect">
             <a:avLst/>
@@ -6681,545 +7299,24 @@
           <a:noFill/>
         </p:spPr>
         <p:txBody>
-          <a:bodyPr wrap="square" anchor="t">
+          <a:bodyPr wrap="square" anchor="ctr">
             <a:spAutoFit/>
           </a:bodyPr>
           <a:lstStyle/>
           <a:p>
-            <a:pPr algn="l">
+            <a:pPr algn="ctr">
               <a:spcAft>
                 <a:spcPts val="600"/>
               </a:spcAft>
             </a:pPr>
             <a:r>
-              <a:rPr sz="1500" b="1">
-                <a:solidFill>
-                  <a:srgbClr val="3FC97A"/>
-                </a:solidFill>
-                <a:latin typeface="Calibri"/>
-              </a:rPr>
-              <a:t>Inspectable &amp; debuggable</a:t>
-            </a:r>
-          </a:p>
-          <a:p>
-            <a:pPr algn="l">
-              <a:spcAft>
-                <a:spcPts val="600"/>
-              </a:spcAft>
-            </a:pPr>
-            <a:r>
-              <a:rPr sz="1300" b="0">
-                <a:solidFill>
-                  <a:srgbClr val="9AA4B2"/>
-                </a:solidFill>
-                <a:latin typeface="Calibri"/>
-              </a:rPr>
-              <a:t>Each agent does one job; the timeline shows exactly who did what, when.</a:t>
-            </a:r>
-          </a:p>
-        </p:txBody>
-      </p:sp>
-      <p:sp>
-        <p:nvSpPr>
-          <p:cNvPr id="7" name="Rectangle 6"/>
-          <p:cNvSpPr/>
-          <p:nvPr/>
-        </p:nvSpPr>
-        <p:spPr>
-          <a:xfrm>
-            <a:off x="4430000" y="1950000"/>
-            <a:ext cx="3450000" cy="1700000"/>
-          </a:xfrm>
-          <a:prstGeom prst="rect">
-            <a:avLst/>
-          </a:prstGeom>
-          <a:solidFill>
-            <a:srgbClr val="151A24"/>
-          </a:solidFill>
-          <a:ln w="12700">
-            <a:solidFill>
-              <a:srgbClr val="2A3140"/>
-            </a:solidFill>
-          </a:ln>
-          <a:effectLst/>
-        </p:spPr>
-        <p:style>
-          <a:lnRef idx="1">
-            <a:schemeClr val="accent1"/>
-          </a:lnRef>
-          <a:fillRef idx="3">
-            <a:schemeClr val="accent1"/>
-          </a:fillRef>
-          <a:effectRef idx="2">
-            <a:schemeClr val="accent1"/>
-          </a:effectRef>
-          <a:fontRef idx="minor">
-            <a:schemeClr val="lt1"/>
-          </a:fontRef>
-        </p:style>
-        <p:txBody>
-          <a:bodyPr rtlCol="0" anchor="ctr"/>
-          <a:lstStyle/>
-          <a:p>
-            <a:pPr algn="ctr"/>
-          </a:p>
-        </p:txBody>
-      </p:sp>
-      <p:sp>
-        <p:nvSpPr>
-          <p:cNvPr id="8" name="TextBox 7"/>
-          <p:cNvSpPr txBox="1"/>
-          <p:nvPr/>
-        </p:nvSpPr>
-        <p:spPr>
-          <a:xfrm>
-            <a:off x="4630000" y="2150000"/>
-            <a:ext cx="3050000" cy="1350000"/>
-          </a:xfrm>
-          <a:prstGeom prst="rect">
-            <a:avLst/>
-          </a:prstGeom>
-          <a:noFill/>
-        </p:spPr>
-        <p:txBody>
-          <a:bodyPr wrap="square" anchor="t">
-            <a:spAutoFit/>
-          </a:bodyPr>
-          <a:lstStyle/>
-          <a:p>
-            <a:pPr algn="l">
-              <a:spcAft>
-                <a:spcPts val="600"/>
-              </a:spcAft>
-            </a:pPr>
-            <a:r>
-              <a:rPr sz="1500" b="1">
-                <a:solidFill>
-                  <a:srgbClr val="3FC97A"/>
-                </a:solidFill>
-                <a:latin typeface="Calibri"/>
-              </a:rPr>
-              <a:t>Measurably better over time</a:t>
-            </a:r>
-          </a:p>
-          <a:p>
-            <a:pPr algn="l">
-              <a:spcAft>
-                <a:spcPts val="600"/>
-              </a:spcAft>
-            </a:pPr>
-            <a:r>
-              <a:rPr sz="1300" b="0">
-                <a:solidFill>
-                  <a:srgbClr val="9AA4B2"/>
-                </a:solidFill>
-                <a:latin typeface="Calibri"/>
-              </a:rPr>
-              <a:t>Versioned rubric + benchmarks turn 'did it help?' into a number, not a vibe.</a:t>
-            </a:r>
-          </a:p>
-        </p:txBody>
-      </p:sp>
-      <p:sp>
-        <p:nvSpPr>
-          <p:cNvPr id="9" name="Rectangle 8"/>
-          <p:cNvSpPr/>
-          <p:nvPr/>
-        </p:nvSpPr>
-        <p:spPr>
-          <a:xfrm>
-            <a:off x="8160000" y="1950000"/>
-            <a:ext cx="3450000" cy="1700000"/>
-          </a:xfrm>
-          <a:prstGeom prst="rect">
-            <a:avLst/>
-          </a:prstGeom>
-          <a:solidFill>
-            <a:srgbClr val="151A24"/>
-          </a:solidFill>
-          <a:ln w="12700">
-            <a:solidFill>
-              <a:srgbClr val="2A3140"/>
-            </a:solidFill>
-          </a:ln>
-          <a:effectLst/>
-        </p:spPr>
-        <p:style>
-          <a:lnRef idx="1">
-            <a:schemeClr val="accent1"/>
-          </a:lnRef>
-          <a:fillRef idx="3">
-            <a:schemeClr val="accent1"/>
-          </a:fillRef>
-          <a:effectRef idx="2">
-            <a:schemeClr val="accent1"/>
-          </a:effectRef>
-          <a:fontRef idx="minor">
-            <a:schemeClr val="lt1"/>
-          </a:fontRef>
-        </p:style>
-        <p:txBody>
-          <a:bodyPr rtlCol="0" anchor="ctr"/>
-          <a:lstStyle/>
-          <a:p>
-            <a:pPr algn="ctr"/>
-          </a:p>
-        </p:txBody>
-      </p:sp>
-      <p:sp>
-        <p:nvSpPr>
-          <p:cNvPr id="10" name="TextBox 9"/>
-          <p:cNvSpPr txBox="1"/>
-          <p:nvPr/>
-        </p:nvSpPr>
-        <p:spPr>
-          <a:xfrm>
-            <a:off x="8360000" y="2150000"/>
-            <a:ext cx="3050000" cy="1350000"/>
-          </a:xfrm>
-          <a:prstGeom prst="rect">
-            <a:avLst/>
-          </a:prstGeom>
-          <a:noFill/>
-        </p:spPr>
-        <p:txBody>
-          <a:bodyPr wrap="square" anchor="t">
-            <a:spAutoFit/>
-          </a:bodyPr>
-          <a:lstStyle/>
-          <a:p>
-            <a:pPr algn="l">
-              <a:spcAft>
-                <a:spcPts val="600"/>
-              </a:spcAft>
-            </a:pPr>
-            <a:r>
-              <a:rPr sz="1500" b="1">
-                <a:solidFill>
-                  <a:srgbClr val="3FC97A"/>
-                </a:solidFill>
-                <a:latin typeface="Calibri"/>
-              </a:rPr>
-              <a:t>Safe by construction</a:t>
-            </a:r>
-          </a:p>
-          <a:p>
-            <a:pPr algn="l">
-              <a:spcAft>
-                <a:spcPts val="600"/>
-              </a:spcAft>
-            </a:pPr>
-            <a:r>
-              <a:rPr sz="1300" b="0">
-                <a:solidFill>
-                  <a:srgbClr val="9AA4B2"/>
-                </a:solidFill>
-                <a:latin typeface="Calibri"/>
-              </a:rPr>
-              <a:t>Sandboxed execution, path validation, JWT auth, human-gated external writes.</a:t>
-            </a:r>
-          </a:p>
-        </p:txBody>
-      </p:sp>
-      <p:sp>
-        <p:nvSpPr>
-          <p:cNvPr id="11" name="Rectangle 10"/>
-          <p:cNvSpPr/>
-          <p:nvPr/>
-        </p:nvSpPr>
-        <p:spPr>
-          <a:xfrm>
-            <a:off x="700000" y="3930000"/>
-            <a:ext cx="3450000" cy="1700000"/>
-          </a:xfrm>
-          <a:prstGeom prst="rect">
-            <a:avLst/>
-          </a:prstGeom>
-          <a:solidFill>
-            <a:srgbClr val="151A24"/>
-          </a:solidFill>
-          <a:ln w="12700">
-            <a:solidFill>
-              <a:srgbClr val="2A3140"/>
-            </a:solidFill>
-          </a:ln>
-          <a:effectLst/>
-        </p:spPr>
-        <p:style>
-          <a:lnRef idx="1">
-            <a:schemeClr val="accent1"/>
-          </a:lnRef>
-          <a:fillRef idx="3">
-            <a:schemeClr val="accent1"/>
-          </a:fillRef>
-          <a:effectRef idx="2">
-            <a:schemeClr val="accent1"/>
-          </a:effectRef>
-          <a:fontRef idx="minor">
-            <a:schemeClr val="lt1"/>
-          </a:fontRef>
-        </p:style>
-        <p:txBody>
-          <a:bodyPr rtlCol="0" anchor="ctr"/>
-          <a:lstStyle/>
-          <a:p>
-            <a:pPr algn="ctr"/>
-          </a:p>
-        </p:txBody>
-      </p:sp>
-      <p:sp>
-        <p:nvSpPr>
-          <p:cNvPr id="12" name="TextBox 11"/>
-          <p:cNvSpPr txBox="1"/>
-          <p:nvPr/>
-        </p:nvSpPr>
-        <p:spPr>
-          <a:xfrm>
-            <a:off x="900000" y="4130000"/>
-            <a:ext cx="3050000" cy="1350000"/>
-          </a:xfrm>
-          <a:prstGeom prst="rect">
-            <a:avLst/>
-          </a:prstGeom>
-          <a:noFill/>
-        </p:spPr>
-        <p:txBody>
-          <a:bodyPr wrap="square" anchor="t">
-            <a:spAutoFit/>
-          </a:bodyPr>
-          <a:lstStyle/>
-          <a:p>
-            <a:pPr algn="l">
-              <a:spcAft>
-                <a:spcPts val="600"/>
-              </a:spcAft>
-            </a:pPr>
-            <a:r>
-              <a:rPr sz="1500" b="1">
-                <a:solidFill>
-                  <a:srgbClr val="3FC97A"/>
-                </a:solidFill>
-                <a:latin typeface="Calibri"/>
-              </a:rPr>
-              <a:t>Runs fully local</a:t>
-            </a:r>
-          </a:p>
-          <a:p>
-            <a:pPr algn="l">
-              <a:spcAft>
-                <a:spcPts val="600"/>
-              </a:spcAft>
-            </a:pPr>
-            <a:r>
-              <a:rPr sz="1300" b="0">
-                <a:solidFill>
-                  <a:srgbClr val="9AA4B2"/>
-                </a:solidFill>
-                <a:latin typeface="Calibri"/>
-              </a:rPr>
-              <a:t>Ollama models, no API keys, no data leaving your machine. Swap by config.</a:t>
-            </a:r>
-          </a:p>
-        </p:txBody>
-      </p:sp>
-      <p:sp>
-        <p:nvSpPr>
-          <p:cNvPr id="13" name="Rectangle 12"/>
-          <p:cNvSpPr/>
-          <p:nvPr/>
-        </p:nvSpPr>
-        <p:spPr>
-          <a:xfrm>
-            <a:off x="4430000" y="3930000"/>
-            <a:ext cx="3450000" cy="1700000"/>
-          </a:xfrm>
-          <a:prstGeom prst="rect">
-            <a:avLst/>
-          </a:prstGeom>
-          <a:solidFill>
-            <a:srgbClr val="151A24"/>
-          </a:solidFill>
-          <a:ln w="12700">
-            <a:solidFill>
-              <a:srgbClr val="2A3140"/>
-            </a:solidFill>
-          </a:ln>
-          <a:effectLst/>
-        </p:spPr>
-        <p:style>
-          <a:lnRef idx="1">
-            <a:schemeClr val="accent1"/>
-          </a:lnRef>
-          <a:fillRef idx="3">
-            <a:schemeClr val="accent1"/>
-          </a:fillRef>
-          <a:effectRef idx="2">
-            <a:schemeClr val="accent1"/>
-          </a:effectRef>
-          <a:fontRef idx="minor">
-            <a:schemeClr val="lt1"/>
-          </a:fontRef>
-        </p:style>
-        <p:txBody>
-          <a:bodyPr rtlCol="0" anchor="ctr"/>
-          <a:lstStyle/>
-          <a:p>
-            <a:pPr algn="ctr"/>
-          </a:p>
-        </p:txBody>
-      </p:sp>
-      <p:sp>
-        <p:nvSpPr>
-          <p:cNvPr id="14" name="TextBox 13"/>
-          <p:cNvSpPr txBox="1"/>
-          <p:nvPr/>
-        </p:nvSpPr>
-        <p:spPr>
-          <a:xfrm>
-            <a:off x="4630000" y="4130000"/>
-            <a:ext cx="3050000" cy="1350000"/>
-          </a:xfrm>
-          <a:prstGeom prst="rect">
-            <a:avLst/>
-          </a:prstGeom>
-          <a:noFill/>
-        </p:spPr>
-        <p:txBody>
-          <a:bodyPr wrap="square" anchor="t">
-            <a:spAutoFit/>
-          </a:bodyPr>
-          <a:lstStyle/>
-          <a:p>
-            <a:pPr algn="l">
-              <a:spcAft>
-                <a:spcPts val="600"/>
-              </a:spcAft>
-            </a:pPr>
-            <a:r>
-              <a:rPr sz="1500" b="1">
-                <a:solidFill>
-                  <a:srgbClr val="3FC97A"/>
-                </a:solidFill>
-                <a:latin typeface="Calibri"/>
-              </a:rPr>
-              <a:t>Reproducible</a:t>
-            </a:r>
-          </a:p>
-          <a:p>
-            <a:pPr algn="l">
-              <a:spcAft>
-                <a:spcPts val="600"/>
-              </a:spcAft>
-            </a:pPr>
-            <a:r>
-              <a:rPr sz="1300" b="0">
-                <a:solidFill>
-                  <a:srgbClr val="9AA4B2"/>
-                </a:solidFill>
-                <a:latin typeface="Calibri"/>
-              </a:rPr>
-              <a:t>Deterministic fakes → the whole system tests offline; great for CI &amp; demos.</a:t>
-            </a:r>
-          </a:p>
-        </p:txBody>
-      </p:sp>
-      <p:sp>
-        <p:nvSpPr>
-          <p:cNvPr id="15" name="Rectangle 14"/>
-          <p:cNvSpPr/>
-          <p:nvPr/>
-        </p:nvSpPr>
-        <p:spPr>
-          <a:xfrm>
-            <a:off x="8160000" y="3930000"/>
-            <a:ext cx="3450000" cy="1700000"/>
-          </a:xfrm>
-          <a:prstGeom prst="rect">
-            <a:avLst/>
-          </a:prstGeom>
-          <a:solidFill>
-            <a:srgbClr val="151A24"/>
-          </a:solidFill>
-          <a:ln w="12700">
-            <a:solidFill>
-              <a:srgbClr val="2A3140"/>
-            </a:solidFill>
-          </a:ln>
-          <a:effectLst/>
-        </p:spPr>
-        <p:style>
-          <a:lnRef idx="1">
-            <a:schemeClr val="accent1"/>
-          </a:lnRef>
-          <a:fillRef idx="3">
-            <a:schemeClr val="accent1"/>
-          </a:fillRef>
-          <a:effectRef idx="2">
-            <a:schemeClr val="accent1"/>
-          </a:effectRef>
-          <a:fontRef idx="minor">
-            <a:schemeClr val="lt1"/>
-          </a:fontRef>
-        </p:style>
-        <p:txBody>
-          <a:bodyPr rtlCol="0" anchor="ctr"/>
-          <a:lstStyle/>
-          <a:p>
-            <a:pPr algn="ctr"/>
-          </a:p>
-        </p:txBody>
-      </p:sp>
-      <p:sp>
-        <p:nvSpPr>
-          <p:cNvPr id="16" name="TextBox 15"/>
-          <p:cNvSpPr txBox="1"/>
-          <p:nvPr/>
-        </p:nvSpPr>
-        <p:spPr>
-          <a:xfrm>
-            <a:off x="8360000" y="4130000"/>
-            <a:ext cx="3050000" cy="1350000"/>
-          </a:xfrm>
-          <a:prstGeom prst="rect">
-            <a:avLst/>
-          </a:prstGeom>
-          <a:noFill/>
-        </p:spPr>
-        <p:txBody>
-          <a:bodyPr wrap="square" anchor="t">
-            <a:spAutoFit/>
-          </a:bodyPr>
-          <a:lstStyle/>
-          <a:p>
-            <a:pPr algn="l">
-              <a:spcAft>
-                <a:spcPts val="600"/>
-              </a:spcAft>
-            </a:pPr>
-            <a:r>
-              <a:rPr sz="1500" b="1">
-                <a:solidFill>
-                  <a:srgbClr val="3FC97A"/>
-                </a:solidFill>
-                <a:latin typeface="Calibri"/>
-              </a:rPr>
-              <a:t>Extensible</a:t>
-            </a:r>
-          </a:p>
-          <a:p>
-            <a:pPr algn="l">
-              <a:spcAft>
-                <a:spcPts val="600"/>
-              </a:spcAft>
-            </a:pPr>
-            <a:r>
-              <a:rPr sz="1300" b="0">
-                <a:solidFill>
-                  <a:srgbClr val="9AA4B2"/>
-                </a:solidFill>
-                <a:latin typeface="Calibri"/>
-              </a:rPr>
-              <a:t>Provider abstractions + plugin marketplace; add agents/models without rewrites.</a:t>
+              <a:rPr sz="1400" b="1">
+                <a:solidFill>
+                  <a:srgbClr val="4F9CF5"/>
+                </a:solidFill>
+                <a:latin typeface="Calibri"/>
+              </a:rPr>
+              <a:t>Closed the critique head-on: "to which project?", "no bootstrap", "no sub-30s wow" — all resolved.</a:t>
             </a:r>
           </a:p>
         </p:txBody>
@@ -7320,7 +7417,7 @@
                 </a:solidFill>
                 <a:latin typeface="Calibri"/>
               </a:rPr>
-              <a:t>APPLICATIONS</a:t>
+              <a:t>BENEFITS</a:t>
             </a:r>
           </a:p>
         </p:txBody>
@@ -7359,7 +7456,7 @@
                 </a:solidFill>
                 <a:latin typeface="Calibri"/>
               </a:rPr>
-              <a:t>Two ways to use it</a:t>
+              <a:t>Why this approach pays off</a:t>
             </a:r>
           </a:p>
         </p:txBody>
@@ -7373,7 +7470,7 @@
         <p:spPr>
           <a:xfrm>
             <a:off x="700000" y="1950000"/>
-            <a:ext cx="5300000" cy="3700000"/>
+            <a:ext cx="3450000" cy="1700000"/>
           </a:xfrm>
           <a:prstGeom prst="rect">
             <a:avLst/>
@@ -7383,7 +7480,7 @@
           </a:solidFill>
           <a:ln w="12700">
             <a:solidFill>
-              <a:srgbClr val="4F9CF5"/>
+              <a:srgbClr val="2A3140"/>
             </a:solidFill>
           </a:ln>
           <a:effectLst/>
@@ -7418,8 +7515,8 @@
         </p:nvSpPr>
         <p:spPr>
           <a:xfrm>
-            <a:off x="1000000" y="2150000"/>
-            <a:ext cx="4800000" cy="500000"/>
+            <a:off x="900000" y="2150000"/>
+            <a:ext cx="3050000" cy="1350000"/>
           </a:xfrm>
           <a:prstGeom prst="rect">
             <a:avLst/>
@@ -7438,182 +7535,43 @@
               </a:spcAft>
             </a:pPr>
             <a:r>
-              <a:rPr sz="1400" b="1">
-                <a:solidFill>
-                  <a:srgbClr val="4F9CF5"/>
-                </a:solidFill>
-                <a:latin typeface="Calibri"/>
-              </a:rPr>
-              <a:t>AS AN ENGINEERING TEAM</a:t>
-            </a:r>
-          </a:p>
-        </p:txBody>
-      </p:sp>
-      <p:sp>
-        <p:nvSpPr>
-          <p:cNvPr id="7" name="TextBox 6"/>
-          <p:cNvSpPr txBox="1"/>
-          <p:nvPr/>
-        </p:nvSpPr>
-        <p:spPr>
-          <a:xfrm>
-            <a:off x="1000000" y="2700000"/>
-            <a:ext cx="4800000" cy="2800000"/>
-          </a:xfrm>
-          <a:prstGeom prst="rect">
-            <a:avLst/>
-          </a:prstGeom>
-          <a:noFill/>
-        </p:spPr>
-        <p:txBody>
-          <a:bodyPr wrap="square">
-            <a:spAutoFit/>
-          </a:bodyPr>
-          <a:lstStyle/>
-          <a:p>
-            <a:pPr>
-              <a:spcAft>
-                <a:spcPts val="1200"/>
-              </a:spcAft>
-            </a:pPr>
-            <a:r>
-              <a:rPr sz="1400" b="1">
-                <a:solidFill>
-                  <a:srgbClr val="4F9CF5"/>
-                </a:solidFill>
-              </a:rPr>
-              <a:t>▸ </a:t>
-            </a:r>
-            <a:r>
-              <a:rPr sz="1400" b="1">
-                <a:solidFill>
-                  <a:srgbClr val="F2F4F8"/>
-                </a:solidFill>
-                <a:latin typeface="Calibri"/>
-              </a:rPr>
-              <a:t>Developers</a:t>
-            </a:r>
-            <a:r>
-              <a:rPr sz="1400">
+              <a:rPr sz="1500" b="1">
+                <a:solidFill>
+                  <a:srgbClr val="3FC97A"/>
+                </a:solidFill>
+                <a:latin typeface="Calibri"/>
+              </a:rPr>
+              <a:t>Inspectable &amp; debuggable</a:t>
+            </a:r>
+          </a:p>
+          <a:p>
+            <a:pPr algn="l">
+              <a:spcAft>
+                <a:spcPts val="600"/>
+              </a:spcAft>
+            </a:pPr>
+            <a:r>
+              <a:rPr sz="1300" b="0">
                 <a:solidFill>
                   <a:srgbClr val="9AA4B2"/>
                 </a:solidFill>
                 <a:latin typeface="Calibri"/>
               </a:rPr>
-              <a:t> — offload features, fixes, refactors, tests</a:t>
-            </a:r>
-          </a:p>
-          <a:p>
-            <a:pPr>
-              <a:spcAft>
-                <a:spcPts val="1200"/>
-              </a:spcAft>
-            </a:pPr>
-            <a:r>
-              <a:rPr sz="1400" b="1">
-                <a:solidFill>
-                  <a:srgbClr val="4F9CF5"/>
-                </a:solidFill>
-              </a:rPr>
-              <a:t>▸ </a:t>
-            </a:r>
-            <a:r>
-              <a:rPr sz="1400" b="1">
-                <a:solidFill>
-                  <a:srgbClr val="F2F4F8"/>
-                </a:solidFill>
-                <a:latin typeface="Calibri"/>
-              </a:rPr>
-              <a:t>Startups</a:t>
-            </a:r>
-            <a:r>
-              <a:rPr sz="1400">
-                <a:solidFill>
-                  <a:srgbClr val="9AA4B2"/>
-                </a:solidFill>
-                <a:latin typeface="Calibri"/>
-              </a:rPr>
-              <a:t> — ship CRUD APIs &amp; internal tooling fast</a:t>
-            </a:r>
-          </a:p>
-          <a:p>
-            <a:pPr>
-              <a:spcAft>
-                <a:spcPts val="1200"/>
-              </a:spcAft>
-            </a:pPr>
-            <a:r>
-              <a:rPr sz="1400" b="1">
-                <a:solidFill>
-                  <a:srgbClr val="4F9CF5"/>
-                </a:solidFill>
-              </a:rPr>
-              <a:t>▸ </a:t>
-            </a:r>
-            <a:r>
-              <a:rPr sz="1400" b="1">
-                <a:solidFill>
-                  <a:srgbClr val="F2F4F8"/>
-                </a:solidFill>
-                <a:latin typeface="Calibri"/>
-              </a:rPr>
-              <a:t>Companies</a:t>
-            </a:r>
-            <a:r>
-              <a:rPr sz="1400">
-                <a:solidFill>
-                  <a:srgbClr val="9AA4B2"/>
-                </a:solidFill>
-                <a:latin typeface="Calibri"/>
-              </a:rPr>
-              <a:t> — internal dashboards on local models, RBAC, gated PRs</a:t>
-            </a:r>
-          </a:p>
-          <a:p>
-            <a:pPr>
-              <a:spcAft>
-                <a:spcPts val="1200"/>
-              </a:spcAft>
-            </a:pPr>
-            <a:r>
-              <a:rPr sz="1400" b="1">
-                <a:solidFill>
-                  <a:srgbClr val="4F9CF5"/>
-                </a:solidFill>
-              </a:rPr>
-              <a:t>▸ </a:t>
-            </a:r>
-            <a:r>
-              <a:rPr sz="1400" b="1">
-                <a:solidFill>
-                  <a:srgbClr val="F2F4F8"/>
-                </a:solidFill>
-                <a:latin typeface="Calibri"/>
-              </a:rPr>
-              <a:t>Students</a:t>
-            </a:r>
-            <a:r>
-              <a:rPr sz="1400">
-                <a:solidFill>
-                  <a:srgbClr val="9AA4B2"/>
-                </a:solidFill>
-                <a:latin typeface="Calibri"/>
-              </a:rPr>
-              <a:t> — a transparent reference for how it all fits together</a:t>
-            </a:r>
-          </a:p>
-        </p:txBody>
-      </p:sp>
-      <p:sp>
-        <p:nvSpPr>
-          <p:cNvPr id="8" name="Rectangle 7"/>
+              <a:t>Each agent does one job; the timeline shows exactly who did what, when.</a:t>
+            </a:r>
+          </a:p>
+        </p:txBody>
+      </p:sp>
+      <p:sp>
+        <p:nvSpPr>
+          <p:cNvPr id="7" name="Rectangle 6"/>
           <p:cNvSpPr/>
           <p:nvPr/>
         </p:nvSpPr>
         <p:spPr>
           <a:xfrm>
-            <a:off x="6450000" y="1950000"/>
-            <a:ext cx="5300000" cy="3700000"/>
+            <a:off x="4430000" y="1950000"/>
+            <a:ext cx="3450000" cy="1700000"/>
           </a:xfrm>
           <a:prstGeom prst="rect">
             <a:avLst/>
@@ -7623,7 +7581,7 @@
           </a:solidFill>
           <a:ln w="12700">
             <a:solidFill>
-              <a:srgbClr val="3FC97A"/>
+              <a:srgbClr val="2A3140"/>
             </a:solidFill>
           </a:ln>
           <a:effectLst/>
@@ -7652,14 +7610,14 @@
       </p:sp>
       <p:sp>
         <p:nvSpPr>
-          <p:cNvPr id="9" name="TextBox 8"/>
+          <p:cNvPr id="8" name="TextBox 7"/>
           <p:cNvSpPr txBox="1"/>
           <p:nvPr/>
         </p:nvSpPr>
         <p:spPr>
           <a:xfrm>
-            <a:off x="6750000" y="2150000"/>
-            <a:ext cx="4800000" cy="500000"/>
+            <a:off x="4630000" y="2150000"/>
+            <a:ext cx="3050000" cy="1350000"/>
           </a:xfrm>
           <a:prstGeom prst="rect">
             <a:avLst/>
@@ -7678,14 +7636,76 @@
               </a:spcAft>
             </a:pPr>
             <a:r>
-              <a:rPr sz="1400" b="1">
+              <a:rPr sz="1500" b="1">
                 <a:solidFill>
                   <a:srgbClr val="3FC97A"/>
                 </a:solidFill>
                 <a:latin typeface="Calibri"/>
               </a:rPr>
-              <a:t>AS A RESEARCH SUBSTRATE</a:t>
-            </a:r>
+              <a:t>Measurably better over time</a:t>
+            </a:r>
+          </a:p>
+          <a:p>
+            <a:pPr algn="l">
+              <a:spcAft>
+                <a:spcPts val="600"/>
+              </a:spcAft>
+            </a:pPr>
+            <a:r>
+              <a:rPr sz="1300" b="0">
+                <a:solidFill>
+                  <a:srgbClr val="9AA4B2"/>
+                </a:solidFill>
+                <a:latin typeface="Calibri"/>
+              </a:rPr>
+              <a:t>Versioned rubric + benchmarks turn 'did it help?' into a number, not a vibe.</a:t>
+            </a:r>
+          </a:p>
+        </p:txBody>
+      </p:sp>
+      <p:sp>
+        <p:nvSpPr>
+          <p:cNvPr id="9" name="Rectangle 8"/>
+          <p:cNvSpPr/>
+          <p:nvPr/>
+        </p:nvSpPr>
+        <p:spPr>
+          <a:xfrm>
+            <a:off x="8160000" y="1950000"/>
+            <a:ext cx="3450000" cy="1700000"/>
+          </a:xfrm>
+          <a:prstGeom prst="rect">
+            <a:avLst/>
+          </a:prstGeom>
+          <a:solidFill>
+            <a:srgbClr val="151A24"/>
+          </a:solidFill>
+          <a:ln w="12700">
+            <a:solidFill>
+              <a:srgbClr val="2A3140"/>
+            </a:solidFill>
+          </a:ln>
+          <a:effectLst/>
+        </p:spPr>
+        <p:style>
+          <a:lnRef idx="1">
+            <a:schemeClr val="accent1"/>
+          </a:lnRef>
+          <a:fillRef idx="3">
+            <a:schemeClr val="accent1"/>
+          </a:fillRef>
+          <a:effectRef idx="2">
+            <a:schemeClr val="accent1"/>
+          </a:effectRef>
+          <a:fontRef idx="minor">
+            <a:schemeClr val="lt1"/>
+          </a:fontRef>
+        </p:style>
+        <p:txBody>
+          <a:bodyPr rtlCol="0" anchor="ctr"/>
+          <a:lstStyle/>
+          <a:p>
+            <a:pPr algn="ctr"/>
           </a:p>
         </p:txBody>
       </p:sp>
@@ -7697,8 +7717,8 @@
         </p:nvSpPr>
         <p:spPr>
           <a:xfrm>
-            <a:off x="6750000" y="2700000"/>
-            <a:ext cx="4800000" cy="2800000"/>
+            <a:off x="8360000" y="2150000"/>
+            <a:ext cx="3050000" cy="1350000"/>
           </a:xfrm>
           <a:prstGeom prst="rect">
             <a:avLst/>
@@ -7706,140 +7726,343 @@
           <a:noFill/>
         </p:spPr>
         <p:txBody>
-          <a:bodyPr wrap="square">
+          <a:bodyPr wrap="square" anchor="t">
             <a:spAutoFit/>
           </a:bodyPr>
           <a:lstStyle/>
           <a:p>
-            <a:pPr>
-              <a:spcAft>
-                <a:spcPts val="1200"/>
-              </a:spcAft>
-            </a:pPr>
-            <a:r>
-              <a:rPr sz="1400" b="1">
-                <a:solidFill>
-                  <a:srgbClr val="4F9CF5"/>
-                </a:solidFill>
-              </a:rPr>
-              <a:t>▸ </a:t>
-            </a:r>
-            <a:r>
-              <a:rPr sz="1400" b="1">
-                <a:solidFill>
-                  <a:srgbClr val="F2F4F8"/>
-                </a:solidFill>
-                <a:latin typeface="Calibri"/>
-              </a:rPr>
-              <a:t>Agent evaluation</a:t>
-            </a:r>
-            <a:r>
-              <a:rPr sz="1400">
+            <a:pPr algn="l">
+              <a:spcAft>
+                <a:spcPts val="600"/>
+              </a:spcAft>
+            </a:pPr>
+            <a:r>
+              <a:rPr sz="1500" b="1">
+                <a:solidFill>
+                  <a:srgbClr val="3FC97A"/>
+                </a:solidFill>
+                <a:latin typeface="Calibri"/>
+              </a:rPr>
+              <a:t>Safe by construction</a:t>
+            </a:r>
+          </a:p>
+          <a:p>
+            <a:pPr algn="l">
+              <a:spcAft>
+                <a:spcPts val="600"/>
+              </a:spcAft>
+            </a:pPr>
+            <a:r>
+              <a:rPr sz="1300" b="0">
                 <a:solidFill>
                   <a:srgbClr val="9AA4B2"/>
                 </a:solidFill>
                 <a:latin typeface="Calibri"/>
               </a:rPr>
-              <a:t> — rubric + benchmarks + performance DB</a:t>
-            </a:r>
-          </a:p>
-          <a:p>
-            <a:pPr>
-              <a:spcAft>
-                <a:spcPts val="1200"/>
-              </a:spcAft>
-            </a:pPr>
-            <a:r>
-              <a:rPr sz="1400" b="1">
-                <a:solidFill>
-                  <a:srgbClr val="4F9CF5"/>
-                </a:solidFill>
-              </a:rPr>
-              <a:t>▸ </a:t>
-            </a:r>
-            <a:r>
-              <a:rPr sz="1400" b="1">
-                <a:solidFill>
-                  <a:srgbClr val="F2F4F8"/>
-                </a:solidFill>
-                <a:latin typeface="Calibri"/>
-              </a:rPr>
-              <a:t>Prompt engineering at scale</a:t>
-            </a:r>
-            <a:r>
-              <a:rPr sz="1400">
+              <a:t>Sandboxed execution, path validation, JWT auth, human-gated external writes.</a:t>
+            </a:r>
+          </a:p>
+        </p:txBody>
+      </p:sp>
+      <p:sp>
+        <p:nvSpPr>
+          <p:cNvPr id="11" name="Rectangle 10"/>
+          <p:cNvSpPr/>
+          <p:nvPr/>
+        </p:nvSpPr>
+        <p:spPr>
+          <a:xfrm>
+            <a:off x="700000" y="3930000"/>
+            <a:ext cx="3450000" cy="1700000"/>
+          </a:xfrm>
+          <a:prstGeom prst="rect">
+            <a:avLst/>
+          </a:prstGeom>
+          <a:solidFill>
+            <a:srgbClr val="151A24"/>
+          </a:solidFill>
+          <a:ln w="12700">
+            <a:solidFill>
+              <a:srgbClr val="2A3140"/>
+            </a:solidFill>
+          </a:ln>
+          <a:effectLst/>
+        </p:spPr>
+        <p:style>
+          <a:lnRef idx="1">
+            <a:schemeClr val="accent1"/>
+          </a:lnRef>
+          <a:fillRef idx="3">
+            <a:schemeClr val="accent1"/>
+          </a:fillRef>
+          <a:effectRef idx="2">
+            <a:schemeClr val="accent1"/>
+          </a:effectRef>
+          <a:fontRef idx="minor">
+            <a:schemeClr val="lt1"/>
+          </a:fontRef>
+        </p:style>
+        <p:txBody>
+          <a:bodyPr rtlCol="0" anchor="ctr"/>
+          <a:lstStyle/>
+          <a:p>
+            <a:pPr algn="ctr"/>
+          </a:p>
+        </p:txBody>
+      </p:sp>
+      <p:sp>
+        <p:nvSpPr>
+          <p:cNvPr id="12" name="TextBox 11"/>
+          <p:cNvSpPr txBox="1"/>
+          <p:nvPr/>
+        </p:nvSpPr>
+        <p:spPr>
+          <a:xfrm>
+            <a:off x="900000" y="4130000"/>
+            <a:ext cx="3050000" cy="1350000"/>
+          </a:xfrm>
+          <a:prstGeom prst="rect">
+            <a:avLst/>
+          </a:prstGeom>
+          <a:noFill/>
+        </p:spPr>
+        <p:txBody>
+          <a:bodyPr wrap="square" anchor="t">
+            <a:spAutoFit/>
+          </a:bodyPr>
+          <a:lstStyle/>
+          <a:p>
+            <a:pPr algn="l">
+              <a:spcAft>
+                <a:spcPts val="600"/>
+              </a:spcAft>
+            </a:pPr>
+            <a:r>
+              <a:rPr sz="1500" b="1">
+                <a:solidFill>
+                  <a:srgbClr val="3FC97A"/>
+                </a:solidFill>
+                <a:latin typeface="Calibri"/>
+              </a:rPr>
+              <a:t>Runs fully local</a:t>
+            </a:r>
+          </a:p>
+          <a:p>
+            <a:pPr algn="l">
+              <a:spcAft>
+                <a:spcPts val="600"/>
+              </a:spcAft>
+            </a:pPr>
+            <a:r>
+              <a:rPr sz="1300" b="0">
                 <a:solidFill>
                   <a:srgbClr val="9AA4B2"/>
                 </a:solidFill>
                 <a:latin typeface="Calibri"/>
               </a:rPr>
-              <a:t> — versioned prompts as A/B experiments</a:t>
-            </a:r>
-          </a:p>
-          <a:p>
-            <a:pPr>
-              <a:spcAft>
-                <a:spcPts val="1200"/>
-              </a:spcAft>
-            </a:pPr>
-            <a:r>
-              <a:rPr sz="1400" b="1">
-                <a:solidFill>
-                  <a:srgbClr val="4F9CF5"/>
-                </a:solidFill>
-              </a:rPr>
-              <a:t>▸ </a:t>
-            </a:r>
-            <a:r>
-              <a:rPr sz="1400" b="1">
-                <a:solidFill>
-                  <a:srgbClr val="F2F4F8"/>
-                </a:solidFill>
-                <a:latin typeface="Calibri"/>
-              </a:rPr>
-              <a:t>Self-improving agents</a:t>
-            </a:r>
-            <a:r>
-              <a:rPr sz="1400">
+              <a:t>Ollama models, no API keys, no data leaving your machine. Swap by config.</a:t>
+            </a:r>
+          </a:p>
+        </p:txBody>
+      </p:sp>
+      <p:sp>
+        <p:nvSpPr>
+          <p:cNvPr id="13" name="Rectangle 12"/>
+          <p:cNvSpPr/>
+          <p:nvPr/>
+        </p:nvSpPr>
+        <p:spPr>
+          <a:xfrm>
+            <a:off x="4430000" y="3930000"/>
+            <a:ext cx="3450000" cy="1700000"/>
+          </a:xfrm>
+          <a:prstGeom prst="rect">
+            <a:avLst/>
+          </a:prstGeom>
+          <a:solidFill>
+            <a:srgbClr val="151A24"/>
+          </a:solidFill>
+          <a:ln w="12700">
+            <a:solidFill>
+              <a:srgbClr val="2A3140"/>
+            </a:solidFill>
+          </a:ln>
+          <a:effectLst/>
+        </p:spPr>
+        <p:style>
+          <a:lnRef idx="1">
+            <a:schemeClr val="accent1"/>
+          </a:lnRef>
+          <a:fillRef idx="3">
+            <a:schemeClr val="accent1"/>
+          </a:fillRef>
+          <a:effectRef idx="2">
+            <a:schemeClr val="accent1"/>
+          </a:effectRef>
+          <a:fontRef idx="minor">
+            <a:schemeClr val="lt1"/>
+          </a:fontRef>
+        </p:style>
+        <p:txBody>
+          <a:bodyPr rtlCol="0" anchor="ctr"/>
+          <a:lstStyle/>
+          <a:p>
+            <a:pPr algn="ctr"/>
+          </a:p>
+        </p:txBody>
+      </p:sp>
+      <p:sp>
+        <p:nvSpPr>
+          <p:cNvPr id="14" name="TextBox 13"/>
+          <p:cNvSpPr txBox="1"/>
+          <p:nvPr/>
+        </p:nvSpPr>
+        <p:spPr>
+          <a:xfrm>
+            <a:off x="4630000" y="4130000"/>
+            <a:ext cx="3050000" cy="1350000"/>
+          </a:xfrm>
+          <a:prstGeom prst="rect">
+            <a:avLst/>
+          </a:prstGeom>
+          <a:noFill/>
+        </p:spPr>
+        <p:txBody>
+          <a:bodyPr wrap="square" anchor="t">
+            <a:spAutoFit/>
+          </a:bodyPr>
+          <a:lstStyle/>
+          <a:p>
+            <a:pPr algn="l">
+              <a:spcAft>
+                <a:spcPts val="600"/>
+              </a:spcAft>
+            </a:pPr>
+            <a:r>
+              <a:rPr sz="1500" b="1">
+                <a:solidFill>
+                  <a:srgbClr val="3FC97A"/>
+                </a:solidFill>
+                <a:latin typeface="Calibri"/>
+              </a:rPr>
+              <a:t>Reproducible</a:t>
+            </a:r>
+          </a:p>
+          <a:p>
+            <a:pPr algn="l">
+              <a:spcAft>
+                <a:spcPts val="600"/>
+              </a:spcAft>
+            </a:pPr>
+            <a:r>
+              <a:rPr sz="1300" b="0">
                 <a:solidFill>
                   <a:srgbClr val="9AA4B2"/>
                 </a:solidFill>
                 <a:latin typeface="Calibri"/>
               </a:rPr>
-              <a:t> — reflection, debate, learning-from-outcomes</a:t>
-            </a:r>
-          </a:p>
-          <a:p>
-            <a:pPr>
-              <a:spcAft>
-                <a:spcPts val="1200"/>
-              </a:spcAft>
-            </a:pPr>
-            <a:r>
-              <a:rPr sz="1400" b="1">
-                <a:solidFill>
-                  <a:srgbClr val="4F9CF5"/>
-                </a:solidFill>
-              </a:rPr>
-              <a:t>▸ </a:t>
-            </a:r>
-            <a:r>
-              <a:rPr sz="1400" b="1">
-                <a:solidFill>
-                  <a:srgbClr val="F2F4F8"/>
-                </a:solidFill>
-                <a:latin typeface="Calibri"/>
-              </a:rPr>
-              <a:t>Plugin ecosystem</a:t>
-            </a:r>
-            <a:r>
-              <a:rPr sz="1400">
+              <a:t>Deterministic fakes → the whole system tests offline; great for CI &amp; demos.</a:t>
+            </a:r>
+          </a:p>
+        </p:txBody>
+      </p:sp>
+      <p:sp>
+        <p:nvSpPr>
+          <p:cNvPr id="15" name="Rectangle 14"/>
+          <p:cNvSpPr/>
+          <p:nvPr/>
+        </p:nvSpPr>
+        <p:spPr>
+          <a:xfrm>
+            <a:off x="8160000" y="3930000"/>
+            <a:ext cx="3450000" cy="1700000"/>
+          </a:xfrm>
+          <a:prstGeom prst="rect">
+            <a:avLst/>
+          </a:prstGeom>
+          <a:solidFill>
+            <a:srgbClr val="151A24"/>
+          </a:solidFill>
+          <a:ln w="12700">
+            <a:solidFill>
+              <a:srgbClr val="2A3140"/>
+            </a:solidFill>
+          </a:ln>
+          <a:effectLst/>
+        </p:spPr>
+        <p:style>
+          <a:lnRef idx="1">
+            <a:schemeClr val="accent1"/>
+          </a:lnRef>
+          <a:fillRef idx="3">
+            <a:schemeClr val="accent1"/>
+          </a:fillRef>
+          <a:effectRef idx="2">
+            <a:schemeClr val="accent1"/>
+          </a:effectRef>
+          <a:fontRef idx="minor">
+            <a:schemeClr val="lt1"/>
+          </a:fontRef>
+        </p:style>
+        <p:txBody>
+          <a:bodyPr rtlCol="0" anchor="ctr"/>
+          <a:lstStyle/>
+          <a:p>
+            <a:pPr algn="ctr"/>
+          </a:p>
+        </p:txBody>
+      </p:sp>
+      <p:sp>
+        <p:nvSpPr>
+          <p:cNvPr id="16" name="TextBox 15"/>
+          <p:cNvSpPr txBox="1"/>
+          <p:nvPr/>
+        </p:nvSpPr>
+        <p:spPr>
+          <a:xfrm>
+            <a:off x="8360000" y="4130000"/>
+            <a:ext cx="3050000" cy="1350000"/>
+          </a:xfrm>
+          <a:prstGeom prst="rect">
+            <a:avLst/>
+          </a:prstGeom>
+          <a:noFill/>
+        </p:spPr>
+        <p:txBody>
+          <a:bodyPr wrap="square" anchor="t">
+            <a:spAutoFit/>
+          </a:bodyPr>
+          <a:lstStyle/>
+          <a:p>
+            <a:pPr algn="l">
+              <a:spcAft>
+                <a:spcPts val="600"/>
+              </a:spcAft>
+            </a:pPr>
+            <a:r>
+              <a:rPr sz="1500" b="1">
+                <a:solidFill>
+                  <a:srgbClr val="3FC97A"/>
+                </a:solidFill>
+                <a:latin typeface="Calibri"/>
+              </a:rPr>
+              <a:t>Extensible</a:t>
+            </a:r>
+          </a:p>
+          <a:p>
+            <a:pPr algn="l">
+              <a:spcAft>
+                <a:spcPts val="600"/>
+              </a:spcAft>
+            </a:pPr>
+            <a:r>
+              <a:rPr sz="1300" b="0">
                 <a:solidFill>
                   <a:srgbClr val="9AA4B2"/>
                 </a:solidFill>
                 <a:latin typeface="Calibri"/>
               </a:rPr>
-              <a:t> — permissioned, contract-checked agent marketplace</a:t>
+              <a:t>Provider abstractions + plugin marketplace; add agents/models without rewrites.</a:t>
             </a:r>
           </a:p>
         </p:txBody>
@@ -7940,7 +8163,7 @@
                 </a:solidFill>
                 <a:latin typeface="Calibri"/>
               </a:rPr>
-              <a:t>STACK &amp; STATUS</a:t>
+              <a:t>APPLICATIONS</a:t>
             </a:r>
           </a:p>
         </p:txBody>
@@ -7979,21 +8202,106 @@
                 </a:solidFill>
                 <a:latin typeface="Calibri"/>
               </a:rPr>
-              <a:t>Built, tested, and running</a:t>
-            </a:r>
-          </a:p>
-        </p:txBody>
-      </p:sp>
-      <p:sp>
-        <p:nvSpPr>
-          <p:cNvPr id="5" name="TextBox 4"/>
+              <a:t>Two ways to use it</a:t>
+            </a:r>
+          </a:p>
+        </p:txBody>
+      </p:sp>
+      <p:sp>
+        <p:nvSpPr>
+          <p:cNvPr id="5" name="Rectangle 4"/>
+          <p:cNvSpPr/>
+          <p:nvPr/>
+        </p:nvSpPr>
+        <p:spPr>
+          <a:xfrm>
+            <a:off x="700000" y="1950000"/>
+            <a:ext cx="5300000" cy="3700000"/>
+          </a:xfrm>
+          <a:prstGeom prst="rect">
+            <a:avLst/>
+          </a:prstGeom>
+          <a:solidFill>
+            <a:srgbClr val="151A24"/>
+          </a:solidFill>
+          <a:ln w="12700">
+            <a:solidFill>
+              <a:srgbClr val="4F9CF5"/>
+            </a:solidFill>
+          </a:ln>
+          <a:effectLst/>
+        </p:spPr>
+        <p:style>
+          <a:lnRef idx="1">
+            <a:schemeClr val="accent1"/>
+          </a:lnRef>
+          <a:fillRef idx="3">
+            <a:schemeClr val="accent1"/>
+          </a:fillRef>
+          <a:effectRef idx="2">
+            <a:schemeClr val="accent1"/>
+          </a:effectRef>
+          <a:fontRef idx="minor">
+            <a:schemeClr val="lt1"/>
+          </a:fontRef>
+        </p:style>
+        <p:txBody>
+          <a:bodyPr rtlCol="0" anchor="ctr"/>
+          <a:lstStyle/>
+          <a:p>
+            <a:pPr algn="ctr"/>
+          </a:p>
+        </p:txBody>
+      </p:sp>
+      <p:sp>
+        <p:nvSpPr>
+          <p:cNvPr id="6" name="TextBox 5"/>
           <p:cNvSpPr txBox="1"/>
           <p:nvPr/>
         </p:nvSpPr>
         <p:spPr>
           <a:xfrm>
-            <a:off x="700000" y="1950000"/>
-            <a:ext cx="11000000" cy="2600000"/>
+            <a:off x="1000000" y="2150000"/>
+            <a:ext cx="4800000" cy="500000"/>
+          </a:xfrm>
+          <a:prstGeom prst="rect">
+            <a:avLst/>
+          </a:prstGeom>
+          <a:noFill/>
+        </p:spPr>
+        <p:txBody>
+          <a:bodyPr wrap="square" anchor="t">
+            <a:spAutoFit/>
+          </a:bodyPr>
+          <a:lstStyle/>
+          <a:p>
+            <a:pPr algn="l">
+              <a:spcAft>
+                <a:spcPts val="600"/>
+              </a:spcAft>
+            </a:pPr>
+            <a:r>
+              <a:rPr sz="1400" b="1">
+                <a:solidFill>
+                  <a:srgbClr val="4F9CF5"/>
+                </a:solidFill>
+                <a:latin typeface="Calibri"/>
+              </a:rPr>
+              <a:t>AS AN ENGINEERING TEAM</a:t>
+            </a:r>
+          </a:p>
+        </p:txBody>
+      </p:sp>
+      <p:sp>
+        <p:nvSpPr>
+          <p:cNvPr id="7" name="TextBox 6"/>
+          <p:cNvSpPr txBox="1"/>
+          <p:nvPr/>
+        </p:nvSpPr>
+        <p:spPr>
+          <a:xfrm>
+            <a:off x="1000000" y="2700000"/>
+            <a:ext cx="4800000" cy="2800000"/>
           </a:xfrm>
           <a:prstGeom prst="rect">
             <a:avLst/>
@@ -8008,11 +8316,11 @@
           <a:p>
             <a:pPr>
               <a:spcAft>
-                <a:spcPts val="1100"/>
-              </a:spcAft>
-            </a:pPr>
-            <a:r>
-              <a:rPr sz="1600" b="1">
+                <a:spcPts val="1200"/>
+              </a:spcAft>
+            </a:pPr>
+            <a:r>
+              <a:rPr sz="1400" b="1">
                 <a:solidFill>
                   <a:srgbClr val="4F9CF5"/>
                 </a:solidFill>
@@ -8020,32 +8328,32 @@
               <a:t>▸ </a:t>
             </a:r>
             <a:r>
-              <a:rPr sz="1600" b="1">
+              <a:rPr sz="1400" b="1">
                 <a:solidFill>
                   <a:srgbClr val="F2F4F8"/>
                 </a:solidFill>
                 <a:latin typeface="Calibri"/>
               </a:rPr>
-              <a:t>Frontend</a:t>
-            </a:r>
-            <a:r>
-              <a:rPr sz="1600">
+              <a:t>Developers</a:t>
+            </a:r>
+            <a:r>
+              <a:rPr sz="1400">
                 <a:solidFill>
                   <a:srgbClr val="9AA4B2"/>
                 </a:solidFill>
                 <a:latin typeface="Calibri"/>
               </a:rPr>
-              <a:t> — Next.js · React · TypeScript · Tailwind</a:t>
+              <a:t> — offload features, fixes, refactors, tests</a:t>
             </a:r>
           </a:p>
           <a:p>
             <a:pPr>
               <a:spcAft>
-                <a:spcPts val="1100"/>
-              </a:spcAft>
-            </a:pPr>
-            <a:r>
-              <a:rPr sz="1600" b="1">
+                <a:spcPts val="1200"/>
+              </a:spcAft>
+            </a:pPr>
+            <a:r>
+              <a:rPr sz="1400" b="1">
                 <a:solidFill>
                   <a:srgbClr val="4F9CF5"/>
                 </a:solidFill>
@@ -8053,32 +8361,32 @@
               <a:t>▸ </a:t>
             </a:r>
             <a:r>
-              <a:rPr sz="1600" b="1">
+              <a:rPr sz="1400" b="1">
                 <a:solidFill>
                   <a:srgbClr val="F2F4F8"/>
                 </a:solidFill>
                 <a:latin typeface="Calibri"/>
               </a:rPr>
-              <a:t>Backend</a:t>
-            </a:r>
-            <a:r>
-              <a:rPr sz="1600">
+              <a:t>Startups</a:t>
+            </a:r>
+            <a:r>
+              <a:rPr sz="1400">
                 <a:solidFill>
                   <a:srgbClr val="9AA4B2"/>
                 </a:solidFill>
                 <a:latin typeface="Calibri"/>
               </a:rPr>
-              <a:t> — FastAPI · LangGraph · SQLAlchemy (async) · WebSockets</a:t>
+              <a:t> — ship CRUD APIs &amp; internal tooling fast</a:t>
             </a:r>
           </a:p>
           <a:p>
             <a:pPr>
               <a:spcAft>
-                <a:spcPts val="1100"/>
-              </a:spcAft>
-            </a:pPr>
-            <a:r>
-              <a:rPr sz="1600" b="1">
+                <a:spcPts val="1200"/>
+              </a:spcAft>
+            </a:pPr>
+            <a:r>
+              <a:rPr sz="1400" b="1">
                 <a:solidFill>
                   <a:srgbClr val="4F9CF5"/>
                 </a:solidFill>
@@ -8086,32 +8394,32 @@
               <a:t>▸ </a:t>
             </a:r>
             <a:r>
-              <a:rPr sz="1600" b="1">
+              <a:rPr sz="1400" b="1">
                 <a:solidFill>
                   <a:srgbClr val="F2F4F8"/>
                 </a:solidFill>
                 <a:latin typeface="Calibri"/>
               </a:rPr>
-              <a:t>Data</a:t>
-            </a:r>
-            <a:r>
-              <a:rPr sz="1600">
+              <a:t>Companies</a:t>
+            </a:r>
+            <a:r>
+              <a:rPr sz="1400">
                 <a:solidFill>
                   <a:srgbClr val="9AA4B2"/>
                 </a:solidFill>
                 <a:latin typeface="Calibri"/>
               </a:rPr>
-              <a:t> — PostgreSQL · Redis · Qdrant</a:t>
+              <a:t> — internal dashboards on local models, RBAC, gated PRs</a:t>
             </a:r>
           </a:p>
           <a:p>
             <a:pPr>
               <a:spcAft>
-                <a:spcPts val="1100"/>
-              </a:spcAft>
-            </a:pPr>
-            <a:r>
-              <a:rPr sz="1600" b="1">
+                <a:spcPts val="1200"/>
+              </a:spcAft>
+            </a:pPr>
+            <a:r>
+              <a:rPr sz="1400" b="1">
                 <a:solidFill>
                   <a:srgbClr val="4F9CF5"/>
                 </a:solidFill>
@@ -8119,69 +8427,36 @@
               <a:t>▸ </a:t>
             </a:r>
             <a:r>
-              <a:rPr sz="1600" b="1">
+              <a:rPr sz="1400" b="1">
                 <a:solidFill>
                   <a:srgbClr val="F2F4F8"/>
                 </a:solidFill>
                 <a:latin typeface="Calibri"/>
               </a:rPr>
-              <a:t>AI</a:t>
-            </a:r>
-            <a:r>
-              <a:rPr sz="1600">
+              <a:t>Students</a:t>
+            </a:r>
+            <a:r>
+              <a:rPr sz="1400">
                 <a:solidFill>
                   <a:srgbClr val="9AA4B2"/>
                 </a:solidFill>
                 <a:latin typeface="Calibri"/>
               </a:rPr>
-              <a:t> — Ollama (local) · model-router abstraction · LangGraph</a:t>
-            </a:r>
-          </a:p>
-          <a:p>
-            <a:pPr>
-              <a:spcAft>
-                <a:spcPts val="1100"/>
-              </a:spcAft>
-            </a:pPr>
-            <a:r>
-              <a:rPr sz="1600" b="1">
-                <a:solidFill>
-                  <a:srgbClr val="4F9CF5"/>
-                </a:solidFill>
-              </a:rPr>
-              <a:t>▸ </a:t>
-            </a:r>
-            <a:r>
-              <a:rPr sz="1600" b="1">
-                <a:solidFill>
-                  <a:srgbClr val="F2F4F8"/>
-                </a:solidFill>
-                <a:latin typeface="Calibri"/>
-              </a:rPr>
-              <a:t>Infra</a:t>
-            </a:r>
-            <a:r>
-              <a:rPr sz="1600">
-                <a:solidFill>
-                  <a:srgbClr val="9AA4B2"/>
-                </a:solidFill>
-                <a:latin typeface="Calibri"/>
-              </a:rPr>
-              <a:t> — Docker · Docker Compose</a:t>
-            </a:r>
-          </a:p>
-        </p:txBody>
-      </p:sp>
-      <p:sp>
-        <p:nvSpPr>
-          <p:cNvPr id="6" name="Rectangle 5"/>
+              <a:t> — a transparent reference for how it all fits together</a:t>
+            </a:r>
+          </a:p>
+        </p:txBody>
+      </p:sp>
+      <p:sp>
+        <p:nvSpPr>
+          <p:cNvPr id="8" name="Rectangle 7"/>
           <p:cNvSpPr/>
           <p:nvPr/>
         </p:nvSpPr>
         <p:spPr>
           <a:xfrm>
-            <a:off x="700000" y="4750000"/>
-            <a:ext cx="10900000" cy="1150000"/>
+            <a:off x="6450000" y="1950000"/>
+            <a:ext cx="5300000" cy="3700000"/>
           </a:xfrm>
           <a:prstGeom prst="rect">
             <a:avLst/>
@@ -8220,14 +8495,14 @@
       </p:sp>
       <p:sp>
         <p:nvSpPr>
-          <p:cNvPr id="7" name="TextBox 6"/>
+          <p:cNvPr id="9" name="TextBox 8"/>
           <p:cNvSpPr txBox="1"/>
           <p:nvPr/>
         </p:nvSpPr>
         <p:spPr>
           <a:xfrm>
-            <a:off x="700000" y="4850000"/>
-            <a:ext cx="10900000" cy="1000000"/>
+            <a:off x="6750000" y="2150000"/>
+            <a:ext cx="4800000" cy="500000"/>
           </a:xfrm>
           <a:prstGeom prst="rect">
             <a:avLst/>
@@ -8235,40 +8510,179 @@
           <a:noFill/>
         </p:spPr>
         <p:txBody>
-          <a:bodyPr wrap="square" anchor="ctr">
+          <a:bodyPr wrap="square" anchor="t">
             <a:spAutoFit/>
           </a:bodyPr>
           <a:lstStyle/>
           <a:p>
-            <a:pPr algn="ctr">
+            <a:pPr algn="l">
               <a:spcAft>
                 <a:spcPts val="600"/>
               </a:spcAft>
             </a:pPr>
             <a:r>
-              <a:rPr sz="1600" b="1">
+              <a:rPr sz="1400" b="1">
                 <a:solidFill>
                   <a:srgbClr val="3FC97A"/>
                 </a:solidFill>
                 <a:latin typeface="Calibri"/>
               </a:rPr>
-              <a:t>All 12 phases complete  ·  310 tests passing  ·  25 ADRs  ·  fully documented</a:t>
-            </a:r>
-          </a:p>
-          <a:p>
-            <a:pPr algn="ctr">
-              <a:spcAft>
-                <a:spcPts val="600"/>
-              </a:spcAft>
-            </a:pPr>
-            <a:r>
-              <a:rPr sz="1400" b="0">
+              <a:t>AS A RESEARCH SUBSTRATE</a:t>
+            </a:r>
+          </a:p>
+        </p:txBody>
+      </p:sp>
+      <p:sp>
+        <p:nvSpPr>
+          <p:cNvPr id="10" name="TextBox 9"/>
+          <p:cNvSpPr txBox="1"/>
+          <p:nvPr/>
+        </p:nvSpPr>
+        <p:spPr>
+          <a:xfrm>
+            <a:off x="6750000" y="2700000"/>
+            <a:ext cx="4800000" cy="2800000"/>
+          </a:xfrm>
+          <a:prstGeom prst="rect">
+            <a:avLst/>
+          </a:prstGeom>
+          <a:noFill/>
+        </p:spPr>
+        <p:txBody>
+          <a:bodyPr wrap="square">
+            <a:spAutoFit/>
+          </a:bodyPr>
+          <a:lstStyle/>
+          <a:p>
+            <a:pPr>
+              <a:spcAft>
+                <a:spcPts val="1200"/>
+              </a:spcAft>
+            </a:pPr>
+            <a:r>
+              <a:rPr sz="1400" b="1">
+                <a:solidFill>
+                  <a:srgbClr val="4F9CF5"/>
+                </a:solidFill>
+              </a:rPr>
+              <a:t>▸ </a:t>
+            </a:r>
+            <a:r>
+              <a:rPr sz="1400" b="1">
+                <a:solidFill>
+                  <a:srgbClr val="F2F4F8"/>
+                </a:solidFill>
+                <a:latin typeface="Calibri"/>
+              </a:rPr>
+              <a:t>Agent evaluation</a:t>
+            </a:r>
+            <a:r>
+              <a:rPr sz="1400">
                 <a:solidFill>
                   <a:srgbClr val="9AA4B2"/>
                 </a:solidFill>
                 <a:latin typeface="Calibri"/>
               </a:rPr>
-              <a:t>From a static pipeline to a self-improving, approval-gated engineering team.</a:t>
+              <a:t> — rubric + benchmarks + performance DB</a:t>
+            </a:r>
+          </a:p>
+          <a:p>
+            <a:pPr>
+              <a:spcAft>
+                <a:spcPts val="1200"/>
+              </a:spcAft>
+            </a:pPr>
+            <a:r>
+              <a:rPr sz="1400" b="1">
+                <a:solidFill>
+                  <a:srgbClr val="4F9CF5"/>
+                </a:solidFill>
+              </a:rPr>
+              <a:t>▸ </a:t>
+            </a:r>
+            <a:r>
+              <a:rPr sz="1400" b="1">
+                <a:solidFill>
+                  <a:srgbClr val="F2F4F8"/>
+                </a:solidFill>
+                <a:latin typeface="Calibri"/>
+              </a:rPr>
+              <a:t>Prompt engineering at scale</a:t>
+            </a:r>
+            <a:r>
+              <a:rPr sz="1400">
+                <a:solidFill>
+                  <a:srgbClr val="9AA4B2"/>
+                </a:solidFill>
+                <a:latin typeface="Calibri"/>
+              </a:rPr>
+              <a:t> — versioned prompts as A/B experiments</a:t>
+            </a:r>
+          </a:p>
+          <a:p>
+            <a:pPr>
+              <a:spcAft>
+                <a:spcPts val="1200"/>
+              </a:spcAft>
+            </a:pPr>
+            <a:r>
+              <a:rPr sz="1400" b="1">
+                <a:solidFill>
+                  <a:srgbClr val="4F9CF5"/>
+                </a:solidFill>
+              </a:rPr>
+              <a:t>▸ </a:t>
+            </a:r>
+            <a:r>
+              <a:rPr sz="1400" b="1">
+                <a:solidFill>
+                  <a:srgbClr val="F2F4F8"/>
+                </a:solidFill>
+                <a:latin typeface="Calibri"/>
+              </a:rPr>
+              <a:t>Self-improving agents</a:t>
+            </a:r>
+            <a:r>
+              <a:rPr sz="1400">
+                <a:solidFill>
+                  <a:srgbClr val="9AA4B2"/>
+                </a:solidFill>
+                <a:latin typeface="Calibri"/>
+              </a:rPr>
+              <a:t> — reflection, debate, learning-from-outcomes</a:t>
+            </a:r>
+          </a:p>
+          <a:p>
+            <a:pPr>
+              <a:spcAft>
+                <a:spcPts val="1200"/>
+              </a:spcAft>
+            </a:pPr>
+            <a:r>
+              <a:rPr sz="1400" b="1">
+                <a:solidFill>
+                  <a:srgbClr val="4F9CF5"/>
+                </a:solidFill>
+              </a:rPr>
+              <a:t>▸ </a:t>
+            </a:r>
+            <a:r>
+              <a:rPr sz="1400" b="1">
+                <a:solidFill>
+                  <a:srgbClr val="F2F4F8"/>
+                </a:solidFill>
+                <a:latin typeface="Calibri"/>
+              </a:rPr>
+              <a:t>Plugin ecosystem</a:t>
+            </a:r>
+            <a:r>
+              <a:rPr sz="1400">
+                <a:solidFill>
+                  <a:srgbClr val="9AA4B2"/>
+                </a:solidFill>
+                <a:latin typeface="Calibri"/>
+              </a:rPr>
+              <a:t> — permissioned, contract-checked agent marketplace</a:t>
             </a:r>
           </a:p>
         </p:txBody>

</xml_diff>

<commit_message>
chore: e2e verification, GitHub PR-execute hardening, doc/artifact refresh
- Verified the full flow live end-to-end (10 steps): register -> workspace ->
  bootstrap fastapi-saas -> agent run -> files on disk -> analytics -> prompt
  comparison -> benchmark trend -> integration honesty. All green; 334 tests.
- GitHub PR execute hardening + clearer errors (github.py, github_execute.py,
  services.py) with a provider test.
- scripts/demo-todo-e2e.sh: scripted register -> bootstrap -> 4 agent runs ->
  approve/execute PRs on a sandbox repo; scripts/wait-api.sh helper; Makefile
  targets.
- README test count -> 334; regenerated ForgeAI-UseCases.pdf (7 pages) and
  ForgeAI-Presentation.pptx (10 slides) with updated counts.
</commit_message>
<xml_diff>
--- a/ForgeAI-Presentation.pptx
+++ b/ForgeAI-Presentation.pptx
@@ -3352,7 +3352,7 @@
                 </a:solidFill>
                 <a:latin typeface="Calibri"/>
               </a:rPr>
-              <a:t>13 phases · 330 tests · fully offline-testable · runs on local models</a:t>
+              <a:t>13 phases · 334 tests · fully offline-testable · runs on local models</a:t>
             </a:r>
           </a:p>
         </p:txBody>
@@ -3765,7 +3765,7 @@
                 </a:solidFill>
                 <a:latin typeface="Calibri"/>
               </a:rPr>
-              <a:t>All 13 phases complete  ·  330 tests passing  ·  26 ADRs  ·  fully documented</a:t>
+              <a:t>All 13 phases complete  ·  334 tests passing  ·  26 ADRs  ·  fully documented</a:t>
             </a:r>
           </a:p>
           <a:p>
@@ -4647,7 +4647,7 @@
                 </a:solidFill>
                 <a:latin typeface="Calibri"/>
               </a:rPr>
-              <a:t> — every external dependency (LLM, GitHub, datastores) has a deterministic fake. 330 tests pass in seconds.</a:t>
+              <a:t> — every external dependency (LLM, GitHub, datastores) has a deterministic fake. 334 tests pass in seconds.</a:t>
             </a:r>
           </a:p>
         </p:txBody>

</xml_diff>